<commit_message>
Sync licensed public-safe source snapshot
Snapshot of the public-safe source tree, built from cc8cf50db54f.
Assembled by tooling/build-public-snapshot.mjs from an explicit allowlist
and checked by tooling/verify-public-snapshot-safety.mjs before publishing.
</commit_message>
<xml_diff>
--- a/tests/fixtures/clioworks-s11/roundtrip-2/edited.pptx
+++ b/tests/fixtures/clioworks-s11/roundtrip-2/edited.pptx
@@ -140,7 +140,7 @@
           </a:p>
         </p188:txBody>
       </p188:reply>
-      <p188:reply xmlns:p188="http://schemas.microsoft.com/office/powerpoint/2018/8/main" id="{4B275DF9-7F61-53E7-AB4D-29F24F444DBC}" authorId="{1A2B3C4D-0000-4000-8000-000000000002}" created="2026-10-16T08:30:00.000Z">
+      <p188:reply xmlns:p188="http://schemas.microsoft.com/office/powerpoint/2018/8/main" id="{9A2A6EB6-2FA4-55FA-8DB4-5189C37EEFF2}" authorId="{1A2B3C4D-0000-4000-8000-000000000002}" created="2026-10-16T08:30:00.000Z">
         <p188:txBody>
           <a:bodyPr xmlns:a="http://schemas.openxmlformats.org/drawingml/2006/main"/>
           <a:lstStyle xmlns:a="http://schemas.openxmlformats.org/drawingml/2006/main"/>
@@ -180,7 +180,7 @@
       </a:p>
     </p188:txBody>
   </p188:cm>
-  <p188:cm xmlns:p188="http://schemas.microsoft.com/office/powerpoint/2018/8/main" id="{4B36A5C2-CC22-51DE-89A8-F1A15C405CF6}" authorId="{1A2B3C4D-0000-4000-8000-000000000001}" created="2026-10-16T08:00:00.000Z">
+  <p188:cm xmlns:p188="http://schemas.microsoft.com/office/powerpoint/2018/8/main" id="{D777AA57-F185-5F8F-89D2-8A771D5C6C03}" authorId="{1A2B3C4D-0000-4000-8000-000000000001}" created="2026-10-16T08:00:00.000Z">
     <ac:deMkLst xmlns:ac="http://schemas.microsoft.com/office/drawing/2013/main/command" xmlns:pc="http://schemas.microsoft.com/office/powerpoint/2013/main/command">
       <pc:docMk/>
       <pc:sldMk cId="2010101010" sldId="256"/>
@@ -3931,7 +3931,7 @@
 </file>
 
 <file path=ppt/slides/slide2.xml><?xml version="1.0" encoding="utf-8"?>
-<p:sld xmlns:a="http://schemas.openxmlformats.org/drawingml/2006/main" xmlns:r="http://schemas.openxmlformats.org/officeDocument/2006/relationships" xmlns:p="http://schemas.openxmlformats.org/presentationml/2006/main">
+<p:sld xmlns:a="http://schemas.openxmlformats.org/drawingml/2006/main" xmlns:p="http://schemas.openxmlformats.org/presentationml/2006/main" xmlns:r="http://schemas.openxmlformats.org/officeDocument/2006/relationships">
   <p:cSld>
     <p:bg>
       <p:bgPr>
@@ -3947,14 +3947,7 @@
         <p:cNvGrpSpPr/>
         <p:nvPr/>
       </p:nvGrpSpPr>
-      <p:grpSpPr>
-        <a:xfrm>
-          <a:off x="0" y="0"/>
-          <a:ext cx="0" cy="0"/>
-          <a:chOff x="0" y="0"/>
-          <a:chExt cx="0" cy="0"/>
-        </a:xfrm>
-      </p:grpSpPr>
+      <p:grpSpPr/>
       <p:sp>
         <p:nvSpPr>
           <p:cNvPr id="2" name="TextBox 1"/>
@@ -3986,10 +3979,8 @@
               </a:defRPr>
             </a:pPr>
             <a:r>
-              <a:rPr lang="en-US" dirty="0"/>
               <a:t>ClioWorks · 合成格式夹具</a:t>
             </a:r>
-            <a:endParaRPr lang="en-US" dirty="0"/>
           </a:p>
         </p:txBody>
       </p:sp>
@@ -4024,10 +4015,8 @@
               </a:defRPr>
             </a:pPr>
             <a:r>
-              <a:rPr lang="en-US" dirty="0"/>
               <a:t>先给出证据，再说明边界</a:t>
             </a:r>
-            <a:endParaRPr lang="en-US" dirty="0"/>
           </a:p>
         </p:txBody>
       </p:sp>
@@ -4062,10 +4051,8 @@
               </a:defRPr>
             </a:pPr>
             <a:r>
-              <a:rPr lang="en-US" dirty="0"/>
               <a:t>正文、数据和演示保留各自的编辑状态。</a:t>
             </a:r>
-            <a:endParaRPr lang="en-US" dirty="0"/>
           </a:p>
           <a:p>
             <a:pPr>
@@ -4077,10 +4064,8 @@
               </a:defRPr>
             </a:pPr>
             <a:r>
-              <a:rPr lang="en-US" dirty="0"/>
               <a:t>来源改变后，作者决定更新哪些副本。</a:t>
             </a:r>
-            <a:endParaRPr lang="en-US" dirty="0"/>
           </a:p>
         </p:txBody>
       </p:sp>
@@ -4115,10 +4100,8 @@
               </a:defRPr>
             </a:pPr>
             <a:r>
-              <a:rPr lang="en-US" dirty="0"/>
               <a:t>不代表真实设备测量；文字是原生可编辑对象。</a:t>
             </a:r>
-            <a:endParaRPr lang="en-US" dirty="0"/>
           </a:p>
         </p:txBody>
       </p:sp>

</xml_diff>